<commit_message>
Deck v10 final: reserve $10M (waterfall sums to $60M); speaker notes removed from all slides
Co-Authored-By: Claude Fable 5.1 <noreply@anthropic.com>
Claude-Session: https://claude.ai/code/session_016cGM8N4AP69rY41a4ajBjX
</commit_message>
<xml_diff>
--- a/deck/CFO_CoS_deck_v10.pptx
+++ b/deck/CFO_CoS_deck_v10.pptx
@@ -374,7 +374,7 @@
                         </a:solidFill>
                         <a:latin typeface="Arial"/>
                       </a:rPr>
-                      <a:t>$5M</a:t>
+                      <a:t>$10M</a:t>
                     </a:r>
                   </a:p>
                 </c:rich>
@@ -552,7 +552,7 @@
                   <c:v>60</c:v>
                 </c:pt>
                 <c:pt idx="1">
-                  <c:v>5</c:v>
+                  <c:v>10</c:v>
                 </c:pt>
                 <c:pt idx="2">
                   <c:v>25</c:v>
@@ -828,11 +828,7 @@
         <p:txBody>
           <a:bodyPr/>
           <a:lstStyle/>
-          <a:p>
-            <a:r>
-              <a:t>Three problems at once; finance and governance as growth levers, adding the rigor scale requires without losing speed.</a:t>
-            </a:r>
-          </a:p>
+          <a:p/>
         </p:txBody>
       </p:sp>
       <p:sp>
@@ -898,11 +894,7 @@
         <p:txBody>
           <a:bodyPr/>
           <a:lstStyle/>
-          <a:p>
-            <a:r>
-              <a:t>The HQ is a governance project: four hard tests before five criteria; two sites to term sheet; the CEO and CFO prioritize.</a:t>
-            </a:r>
-          </a:p>
+          <a:p/>
         </p:txBody>
       </p:sp>
       <p:sp>
@@ -968,11 +960,7 @@
         <p:txBody>
           <a:bodyPr/>
           <a:lstStyle/>
-          <a:p>
-            <a:r>
-              <a:t>SMEs own the judgment, CoS &amp; CG owns the process, the CFO owns the recommendation; disagreements reach the CFO within 48 hours.</a:t>
-            </a:r>
-          </a:p>
+          <a:p/>
         </p:txBody>
       </p:sp>
       <p:sp>
@@ -1038,11 +1026,7 @@
         <p:txBody>
           <a:bodyPr/>
           <a:lstStyle/>
-          <a:p>
-            <a:r>
-              <a:t>Four decision gates in 120 days: can we, what may we offer, who may bind Nu, do we commit; nothing signed between them.</a:t>
-            </a:r>
-          </a:p>
+          <a:p/>
         </p:txBody>
       </p:sp>
       <p:sp>
@@ -1108,11 +1092,7 @@
         <p:txBody>
           <a:bodyPr/>
           <a:lstStyle/>
-          <a:p>
-            <a:r>
-              <a:t>Trust, alignment, execution, learning. Initial boundaries (first 90 days): local-CFO decision rights in Mexico and Colombia, credit-model governance and the IR calendar stay as they are. Commitments: quarterly keep / fix / drop review with the CFO; GM feedback twice a year; every action with an owner and a date.</a:t>
-            </a:r>
-          </a:p>
+          <a:p/>
         </p:txBody>
       </p:sp>
       <p:sp>
@@ -1178,11 +1158,7 @@
         <p:txBody>
           <a:bodyPr/>
           <a:lstStyle/>
-          <a:p>
-            <a:r>
-              <a:t>Who owns what across the three problems; propose, implement, assess; the function earns its place with the markets.</a:t>
-            </a:r>
-          </a:p>
+          <a:p/>
         </p:txBody>
       </p:sp>
       <p:sp>
@@ -1248,11 +1224,7 @@
         <p:txBody>
           <a:bodyPr/>
           <a:lstStyle/>
-          <a:p>
-            <a:r>
-              <a:t>Not presented.</a:t>
-            </a:r>
-          </a:p>
+          <a:p/>
         </p:txBody>
       </p:sp>
       <p:sp>
@@ -1318,11 +1290,7 @@
         <p:txBody>
           <a:bodyPr/>
           <a:lstStyle/>
-          <a:p>
-            <a:r>
-              <a:t>Backup.</a:t>
-            </a:r>
-          </a:p>
+          <a:p/>
         </p:txBody>
       </p:sp>
       <p:sp>
@@ -1388,11 +1356,7 @@
         <p:txBody>
           <a:bodyPr/>
           <a:lstStyle/>
-          <a:p>
-            <a:r>
-              <a:t>Backup.</a:t>
-            </a:r>
-          </a:p>
+          <a:p/>
         </p:txBody>
       </p:sp>
       <p:sp>
@@ -1458,12 +1422,7 @@
         <p:txBody>
           <a:bodyPr/>
           <a:lstStyle/>
-          <a:p>
-            <a:r>
-              <a:rPr dirty="0"/>
-              <a:t>Backup.</a:t>
-            </a:r>
-          </a:p>
+          <a:p/>
         </p:txBody>
       </p:sp>
       <p:sp>
@@ -1529,11 +1488,7 @@
         <p:txBody>
           <a:bodyPr/>
           <a:lstStyle/>
-          <a:p>
-            <a:r>
-              <a:t>Backup.</a:t>
-            </a:r>
-          </a:p>
+          <a:p/>
         </p:txBody>
       </p:sp>
       <p:sp>
@@ -1599,11 +1554,7 @@
         <p:txBody>
           <a:bodyPr/>
           <a:lstStyle/>
-          <a:p>
-            <a:r>
-              <a:t>Ownership as the principle across all four deliverables; success measured in numbers; three decisions requested today.</a:t>
-            </a:r>
-          </a:p>
+          <a:p/>
         </p:txBody>
       </p:sp>
       <p:sp>
@@ -1669,11 +1620,7 @@
         <p:txBody>
           <a:bodyPr/>
           <a:lstStyle/>
-          <a:p>
-            <a:r>
-              <a:t>Backup.</a:t>
-            </a:r>
-          </a:p>
+          <a:p/>
         </p:txBody>
       </p:sp>
       <p:sp>
@@ -1739,11 +1686,7 @@
         <p:txBody>
           <a:bodyPr/>
           <a:lstStyle/>
-          <a:p>
-            <a:r>
-              <a:t>Backup.</a:t>
-            </a:r>
-          </a:p>
+          <a:p/>
         </p:txBody>
       </p:sp>
       <p:sp>
@@ -1827,11 +1770,7 @@
         <p:txBody>
           <a:bodyPr/>
           <a:lstStyle/>
-          <a:p>
-            <a:r>
-              <a:t>A CoE hub of 4-6 people and three meetings; local finance owns the drivers, the hub standardizes and consolidates, the CFO decides.</a:t>
-            </a:r>
-          </a:p>
+          <a:p/>
         </p:txBody>
       </p:sp>
       <p:sp>
@@ -1908,11 +1847,7 @@
         <p:txBody>
           <a:bodyPr/>
           <a:lstStyle/>
-          <a:p>
-            <a:r>
-              <a:t>$35M is about 0.2 points of efficiency ratio; what is broken is the process, so budgets work like Nu's credit: low-and-grow.</a:t>
-            </a:r>
-          </a:p>
+          <a:p/>
         </p:txBody>
       </p:sp>
       <p:sp>
@@ -1966,11 +1901,7 @@
         <p:txBody>
           <a:bodyPr/>
           <a:lstStyle/>
-          <a:p>
-            <a:r>
-              <a:t>Mandatory obligations pass a separate gate; discretionary asks are scored on five weighted criteria; four-step decision process.</a:t>
-            </a:r>
-          </a:p>
+          <a:p/>
         </p:txBody>
       </p:sp>
     </p:spTree>
@@ -2024,11 +1955,7 @@
         <p:txBody>
           <a:bodyPr/>
           <a:lstStyle/>
-          <a:p>
-            <a:r>
-              <a:t>Fund now $25M (the cap), stage up to $25M at the 2H checkpoint on H1 data, $5M reserve; $5M of the $60M is not funded in FY27.</a:t>
-            </a:r>
-          </a:p>
+          <a:p/>
         </p:txBody>
       </p:sp>
       <p:sp>
@@ -2082,11 +2009,7 @@
         <p:txBody>
           <a:bodyPr/>
           <a:lstStyle/>
-          <a:p>
-            <a:r>
-              <a:t>The lead aligns executives; the team runs the calendar and tracks actions; weekly CFO, monthly GMs, T-28 to T-7 before each Board.</a:t>
-            </a:r>
-          </a:p>
+          <a:p/>
         </p:txBody>
       </p:sp>
     </p:spTree>
@@ -2140,11 +2063,7 @@
         <p:txBody>
           <a:bodyPr/>
           <a:lstStyle/>
-          <a:p>
-            <a:r>
-              <a:t>Why the book is late, and the quarterly countdown that fixes it: outline at T-28, lock at T-16, book at T-7.</a:t>
-            </a:r>
-          </a:p>
+          <a:p/>
         </p:txBody>
       </p:sp>
       <p:sp>
@@ -2210,11 +2129,7 @@
         <p:txBody>
           <a:bodyPr/>
           <a:lstStyle/>
-          <a:p>
-            <a:r>
-              <a:t>Four moves for executive friction: private first, beyond the numbers, people, build with not for; dissent but commit.</a:t>
-            </a:r>
-          </a:p>
+          <a:p/>
         </p:txBody>
       </p:sp>
       <p:sp>
@@ -9611,7 +9526,7 @@
                 </a:solidFill>
                 <a:latin typeface="Arial"/>
               </a:rPr>
-              <a:t>Proposed approach. Fair process: Kim and Mauborgne (HBR). Review commitments and initial boundaries in speaker notes.</a:t>
+              <a:t>Proposed approach. Fair process: Kim and Mauborgne (HBR).</a:t>
             </a:r>
           </a:p>
         </p:txBody>
@@ -12403,7 +12318,7 @@
                           </a:solidFill>
                           <a:latin typeface="Arial"/>
                         </a:rPr>
-                        <a:t>FY27 envelope: first release 1 Jan 2027, second at Q1 close (decided on Q1 data), 2H checkpoint (up to $25M) and reserve ($5M) at H1 close. Hub of 4-6 people.</a:t>
+                        <a:t>FY27 envelope: first release 1 Jan 2027, second at Q1 close (decided on Q1 data), 2H checkpoint (up to $25M) and reserve ($10M) at H1 close. Hub of 4-6 people.</a:t>
                       </a:r>
                     </a:p>
                   </a:txBody>
@@ -24368,7 +24283,7 @@
                 </a:solidFill>
                 <a:latin typeface="Arial"/>
               </a:rPr>
-              <a:t>$5M</a:t>
+              <a:t>$10M</a:t>
             </a:r>
             <a:endParaRPr sz="1200" b="0" dirty="0">
               <a:solidFill>
@@ -24458,7 +24373,7 @@
                 </a:solidFill>
                 <a:latin typeface="Arial"/>
               </a:rPr>
-              <a:t>The two releases ($25M) are the cap. The 2H checkpoint (up to $25M) and the reserve ($5M) sit outside the plan and open only on the conditions stated; $5M of the $60M is not funded in FY27. The 70/30 split follows mature cohorts: ~$31 of monthly ARPAC at eight years against $17.1 for the group (Q1'26 cohort data).</a:t>
+              <a:t>The two releases ($25M) are the cap. The 2H checkpoint (up to $25M) and the reserve ($10M) sit outside the plan and open only on the conditions stated, so every dollar of the $60M has a path. The 70/30 split follows mature cohorts: ~$31 of monthly ARPAC at eight years against $17.1 for the group (Q1'26 cohort data).</a:t>
             </a:r>
           </a:p>
         </p:txBody>

</xml_diff>

<commit_message>
Deck v10: add hub structure, leveling and two-wave hiring schedule (new slide 4)
Co-Authored-By: Claude Fable 5.1 <noreply@anthropic.com>
Claude-Session: https://claude.ai/code/session_016cGM8N4AP69rY41a4ajBjX
</commit_message>
<xml_diff>
--- a/deck/CFO_CoS_deck_v10.pptx
+++ b/deck/CFO_CoS_deck_v10.pptx
@@ -11,6 +11,7 @@
     <p:sldId id="256" r:id="rId2"/>
     <p:sldId id="257" r:id="rId3"/>
     <p:sldId id="282" r:id="rId4"/>
+    <p:sldId id="285" r:id="rId28"/>
     <p:sldId id="259" r:id="rId5"/>
     <p:sldId id="283" r:id="rId6"/>
     <p:sldId id="260" r:id="rId7"/>
@@ -6986,7 +6987,7 @@
                 </a:solidFill>
                 <a:latin typeface="Arial"/>
               </a:rPr>
-              <a:t>10</a:t>
+              <a:t>11</a:t>
             </a:r>
           </a:p>
         </p:txBody>
@@ -8314,7 +8315,7 @@
                 </a:solidFill>
                 <a:latin typeface="Arial"/>
               </a:rPr>
-              <a:t>11</a:t>
+              <a:t>12</a:t>
             </a:r>
             <a:endParaRPr sz="900" b="0">
               <a:solidFill>
@@ -9322,7 +9323,7 @@
                 </a:solidFill>
                 <a:latin typeface="Arial"/>
               </a:rPr>
-              <a:t>12</a:t>
+              <a:t>13</a:t>
             </a:r>
             <a:endParaRPr sz="900" b="0">
               <a:solidFill>
@@ -9561,7 +9562,7 @@
                 </a:solidFill>
                 <a:latin typeface="Arial"/>
               </a:rPr>
-              <a:t>13</a:t>
+              <a:t>14</a:t>
             </a:r>
           </a:p>
         </p:txBody>
@@ -11289,7 +11290,7 @@
                 </a:solidFill>
                 <a:latin typeface="Arial"/>
               </a:rPr>
-              <a:t>14</a:t>
+              <a:t>15</a:t>
             </a:r>
           </a:p>
         </p:txBody>
@@ -11451,7 +11452,7 @@
                 </a:solidFill>
                 <a:latin typeface="Arial"/>
               </a:rPr>
-              <a:t>15</a:t>
+              <a:t>16</a:t>
             </a:r>
             <a:endParaRPr sz="900" b="0">
               <a:solidFill>
@@ -12289,7 +12290,7 @@
                           </a:solidFill>
                           <a:latin typeface="Arial"/>
                         </a:rPr>
-                        <a:t>Slide 4; backup D</a:t>
+                        <a:t>Slide 5; backup D</a:t>
                       </a:r>
                     </a:p>
                   </a:txBody>
@@ -12570,7 +12571,7 @@
                 </a:solidFill>
                 <a:latin typeface="Arial"/>
               </a:rPr>
-              <a:t>16</a:t>
+              <a:t>17</a:t>
             </a:r>
             <a:endParaRPr sz="900" b="0">
               <a:solidFill>
@@ -13208,7 +13209,7 @@
                 </a:solidFill>
                 <a:latin typeface="Arial"/>
               </a:rPr>
-              <a:t>17</a:t>
+              <a:t>18</a:t>
             </a:r>
             <a:endParaRPr sz="900" b="0">
               <a:solidFill>
@@ -13565,7 +13566,7 @@
                           </a:solidFill>
                           <a:latin typeface="Arial"/>
                         </a:rPr>
-                        <a:t>Slides 4, 6; backup A</a:t>
+                        <a:t>Slides 5, 7; backup A</a:t>
                       </a:r>
                     </a:p>
                   </a:txBody>
@@ -13660,7 +13661,7 @@
                           </a:solidFill>
                           <a:latin typeface="Arial"/>
                         </a:rPr>
-                        <a:t>Slides 8, 12; backup B</a:t>
+                        <a:t>Slides 9, 13; backup B</a:t>
                       </a:r>
                     </a:p>
                   </a:txBody>
@@ -13755,7 +13756,7 @@
                           </a:solidFill>
                           <a:latin typeface="Arial"/>
                         </a:rPr>
-                        <a:t>Slide 6 (70/30 split)</a:t>
+                        <a:t>Slide 7 (70/30 split)</a:t>
                       </a:r>
                     </a:p>
                   </a:txBody>
@@ -13850,7 +13851,7 @@
                           </a:solidFill>
                           <a:latin typeface="Arial"/>
                         </a:rPr>
-                        <a:t>Slide 10</a:t>
+                        <a:t>Slide 11</a:t>
                       </a:r>
                     </a:p>
                   </a:txBody>
@@ -14052,7 +14053,7 @@
                           </a:solidFill>
                           <a:latin typeface="Arial"/>
                         </a:rPr>
-                        <a:t>Slides 2, 3, 7, 13; backup H</a:t>
+                        <a:t>Slides 2, 3, 8, 14; backup H</a:t>
                       </a:r>
                       <a:endParaRPr lang="en-US" sz="1000" b="0" dirty="0">
                         <a:solidFill>
@@ -14200,7 +14201,7 @@
                           <a:ea typeface="+mn-ea"/>
                           <a:cs typeface="+mn-cs"/>
                         </a:rPr>
-                        <a:t>Slide 5</a:t>
+                        <a:t>Slide 6</a:t>
                       </a:r>
                       <a:endParaRPr sz="1000" b="0" kern="1200" dirty="0">
                         <a:solidFill>
@@ -14347,7 +14348,7 @@
                 </a:solidFill>
                 <a:latin typeface="Arial"/>
               </a:rPr>
-              <a:t>18</a:t>
+              <a:t>19</a:t>
             </a:r>
             <a:endParaRPr sz="900" b="0">
               <a:solidFill>
@@ -15862,7 +15863,7 @@
                 </a:solidFill>
                 <a:latin typeface="Arial"/>
               </a:rPr>
-              <a:t>19</a:t>
+              <a:t>20</a:t>
             </a:r>
             <a:endParaRPr sz="900" b="0">
               <a:solidFill>
@@ -17913,7 +17914,7 @@
                 </a:solidFill>
                 <a:latin typeface="Arial"/>
               </a:rPr>
-              <a:t>20</a:t>
+              <a:t>21</a:t>
             </a:r>
             <a:endParaRPr sz="900" b="0">
               <a:solidFill>
@@ -19153,7 +19154,1200 @@
                 </a:solidFill>
                 <a:latin typeface="Arial"/>
               </a:rPr>
-              <a:t>21</a:t>
+              <a:t>22</a:t>
+            </a:r>
+            <a:endParaRPr sz="900" b="0">
+              <a:solidFill>
+                <a:srgbClr val="6B5B82"/>
+              </a:solidFill>
+              <a:latin typeface="Arial"/>
+            </a:endParaRPr>
+          </a:p>
+        </p:txBody>
+      </p:sp>
+    </p:spTree>
+  </p:cSld>
+  <p:clrMapOvr>
+    <a:masterClrMapping/>
+  </p:clrMapOvr>
+</p:sld>
+</file>
+
+<file path=ppt/slides/slide22.xml><?xml version="1.0" encoding="utf-8"?>
+<p:sld xmlns:a="http://schemas.openxmlformats.org/drawingml/2006/main" xmlns:p="http://schemas.openxmlformats.org/presentationml/2006/main" xmlns:r="http://schemas.openxmlformats.org/officeDocument/2006/relationships">
+  <p:cSld>
+    <p:bg>
+      <p:bgPr>
+        <a:solidFill>
+          <a:srgbClr val="FAF8FF"/>
+        </a:solidFill>
+        <a:effectLst/>
+      </p:bgPr>
+    </p:bg>
+    <p:spTree>
+      <p:nvGrpSpPr>
+        <p:cNvPr id="1" name=""/>
+        <p:cNvGrpSpPr/>
+        <p:nvPr/>
+      </p:nvGrpSpPr>
+      <p:grpSpPr/>
+      <p:sp>
+        <p:nvSpPr>
+          <p:cNvPr id="2" name="TextBox 1"/>
+          <p:cNvSpPr txBox="1"/>
+          <p:nvPr/>
+        </p:nvSpPr>
+        <p:spPr>
+          <a:xfrm>
+            <a:off x="612648" y="347472"/>
+            <a:ext cx="10972800" cy="274320"/>
+          </a:xfrm>
+          <a:prstGeom prst="rect">
+            <a:avLst/>
+          </a:prstGeom>
+          <a:noFill/>
+        </p:spPr>
+        <p:txBody>
+          <a:bodyPr wrap="square" anchor="t">
+            <a:spAutoFit/>
+          </a:bodyPr>
+          <a:lstStyle/>
+          <a:p>
+            <a:pPr algn="l"/>
+            <a:r>
+              <a:rPr sz="1000" b="1">
+                <a:solidFill>
+                  <a:srgbClr val="820AD1"/>
+                </a:solidFill>
+                <a:latin typeface="Arial"/>
+              </a:rPr>
+              <a:t>DELIVERABLE 1  //  TEAM</a:t>
+            </a:r>
+          </a:p>
+        </p:txBody>
+      </p:sp>
+      <p:sp>
+        <p:nvSpPr>
+          <p:cNvPr id="3" name="TextBox 2"/>
+          <p:cNvSpPr txBox="1"/>
+          <p:nvPr/>
+        </p:nvSpPr>
+        <p:spPr>
+          <a:xfrm>
+            <a:off x="612648" y="621792"/>
+            <a:ext cx="10972800" cy="868680"/>
+          </a:xfrm>
+          <a:prstGeom prst="rect">
+            <a:avLst/>
+          </a:prstGeom>
+          <a:noFill/>
+        </p:spPr>
+        <p:txBody>
+          <a:bodyPr wrap="square" anchor="t">
+            <a:spAutoFit/>
+          </a:bodyPr>
+          <a:lstStyle/>
+          <a:p>
+            <a:pPr algn="l"/>
+            <a:r>
+              <a:rPr sz="2400" b="1">
+                <a:solidFill>
+                  <a:srgbClr val="11052C"/>
+                </a:solidFill>
+                <a:latin typeface="Arial"/>
+              </a:rPr>
+              <a:t>Hub of 4-6: 2-3 in the countries, 2-3 central in the US, in two waves</a:t>
+            </a:r>
+          </a:p>
+        </p:txBody>
+      </p:sp>
+      <p:graphicFrame>
+        <p:nvGraphicFramePr>
+          <p:cNvPr id="4" name="Table 3"/>
+          <p:cNvGraphicFramePr>
+            <a:graphicFrameLocks noGrp="1"/>
+          </p:cNvGraphicFramePr>
+          <p:nvPr/>
+        </p:nvGraphicFramePr>
+        <p:xfrm>
+          <a:off x="612648" y="1554480"/>
+          <a:ext cx="11064240" cy="3017520"/>
+        </p:xfrm>
+        <a:graphic>
+          <a:graphicData uri="http://schemas.openxmlformats.org/drawingml/2006/table">
+            <a:tbl>
+              <a:tblPr>
+                <a:tableStyleId>{5C22544A-7EE6-4342-B048-85BDC9FD1C3A}</a:tableStyleId>
+              </a:tblPr>
+              <a:tblGrid>
+                <a:gridCol w="4206240"/>
+                <a:gridCol w="1737360"/>
+                <a:gridCol w="1188720"/>
+                <a:gridCol w="2377440"/>
+                <a:gridCol w="1554480"/>
+              </a:tblGrid>
+              <a:tr h="329184">
+                <a:tc>
+                  <a:txBody>
+                    <a:bodyPr/>
+                    <a:lstStyle/>
+                    <a:p>
+                      <a:r>
+                        <a:rPr sz="1100" b="1">
+                          <a:solidFill>
+                            <a:srgbClr val="FFFFFF"/>
+                          </a:solidFill>
+                          <a:latin typeface="Arial"/>
+                        </a:rPr>
+                        <a:t>Role</a:t>
+                      </a:r>
+                    </a:p>
+                  </a:txBody>
+                  <a:tcPr marL="73152" marR="73152" marT="36576" marB="36576" anchor="ctr">
+                    <a:solidFill>
+                      <a:srgbClr val="820AD1"/>
+                    </a:solidFill>
+                  </a:tcPr>
+                </a:tc>
+                <a:tc>
+                  <a:txBody>
+                    <a:bodyPr/>
+                    <a:lstStyle/>
+                    <a:p>
+                      <a:r>
+                        <a:rPr sz="1100" b="1">
+                          <a:solidFill>
+                            <a:srgbClr val="FFFFFF"/>
+                          </a:solidFill>
+                          <a:latin typeface="Arial"/>
+                        </a:rPr>
+                        <a:t>Level (proposal)</a:t>
+                      </a:r>
+                    </a:p>
+                  </a:txBody>
+                  <a:tcPr marL="73152" marR="73152" marT="36576" marB="36576" anchor="ctr">
+                    <a:solidFill>
+                      <a:srgbClr val="820AD1"/>
+                    </a:solidFill>
+                  </a:tcPr>
+                </a:tc>
+                <a:tc>
+                  <a:txBody>
+                    <a:bodyPr/>
+                    <a:lstStyle/>
+                    <a:p>
+                      <a:r>
+                        <a:rPr sz="1100" b="1">
+                          <a:solidFill>
+                            <a:srgbClr val="FFFFFF"/>
+                          </a:solidFill>
+                          <a:latin typeface="Arial"/>
+                        </a:rPr>
+                        <a:t>Where</a:t>
+                      </a:r>
+                    </a:p>
+                  </a:txBody>
+                  <a:tcPr marL="73152" marR="73152" marT="36576" marB="36576" anchor="ctr">
+                    <a:solidFill>
+                      <a:srgbClr val="820AD1"/>
+                    </a:solidFill>
+                  </a:tcPr>
+                </a:tc>
+                <a:tc>
+                  <a:txBody>
+                    <a:bodyPr/>
+                    <a:lstStyle/>
+                    <a:p>
+                      <a:r>
+                        <a:rPr sz="1100" b="1">
+                          <a:solidFill>
+                            <a:srgbClr val="FFFFFF"/>
+                          </a:solidFill>
+                          <a:latin typeface="Arial"/>
+                        </a:rPr>
+                        <a:t>Reports to</a:t>
+                      </a:r>
+                    </a:p>
+                  </a:txBody>
+                  <a:tcPr marL="73152" marR="73152" marT="36576" marB="36576" anchor="ctr">
+                    <a:solidFill>
+                      <a:srgbClr val="820AD1"/>
+                    </a:solidFill>
+                  </a:tcPr>
+                </a:tc>
+                <a:tc>
+                  <a:txBody>
+                    <a:bodyPr/>
+                    <a:lstStyle/>
+                    <a:p>
+                      <a:r>
+                        <a:rPr sz="1100" b="1">
+                          <a:solidFill>
+                            <a:srgbClr val="FFFFFF"/>
+                          </a:solidFill>
+                          <a:latin typeface="Arial"/>
+                        </a:rPr>
+                        <a:t>Wave</a:t>
+                      </a:r>
+                    </a:p>
+                  </a:txBody>
+                  <a:tcPr marL="73152" marR="73152" marT="36576" marB="36576" anchor="ctr">
+                    <a:solidFill>
+                      <a:srgbClr val="820AD1"/>
+                    </a:solidFill>
+                  </a:tcPr>
+                </a:tc>
+              </a:tr>
+              <a:tr h="384048">
+                <a:tc>
+                  <a:txBody>
+                    <a:bodyPr/>
+                    <a:lstStyle/>
+                    <a:p>
+                      <a:r>
+                        <a:rPr sz="1050" b="1">
+                          <a:solidFill>
+                            <a:srgbClr val="11052C"/>
+                          </a:solidFill>
+                          <a:latin typeface="Arial"/>
+                        </a:rPr>
+                        <a:t>Hub lead: CoS &amp; Corporate Governance</a:t>
+                      </a:r>
+                    </a:p>
+                  </a:txBody>
+                  <a:tcPr marL="73152" marR="73152" marT="36576" marB="36576" anchor="ctr">
+                    <a:solidFill>
+                      <a:srgbClr val="FFFFFF"/>
+                    </a:solidFill>
+                  </a:tcPr>
+                </a:tc>
+                <a:tc>
+                  <a:txBody>
+                    <a:bodyPr/>
+                    <a:lstStyle/>
+                    <a:p>
+                      <a:r>
+                        <a:rPr sz="1050" b="0">
+                          <a:solidFill>
+                            <a:srgbClr val="3B2A54"/>
+                          </a:solidFill>
+                          <a:latin typeface="Arial"/>
+                        </a:rPr>
+                        <a:t>Existing role</a:t>
+                      </a:r>
+                    </a:p>
+                  </a:txBody>
+                  <a:tcPr marL="73152" marR="73152" marT="36576" marB="36576" anchor="ctr">
+                    <a:solidFill>
+                      <a:srgbClr val="FFFFFF"/>
+                    </a:solidFill>
+                  </a:tcPr>
+                </a:tc>
+                <a:tc>
+                  <a:txBody>
+                    <a:bodyPr/>
+                    <a:lstStyle/>
+                    <a:p>
+                      <a:r>
+                        <a:rPr sz="1050" b="0">
+                          <a:solidFill>
+                            <a:srgbClr val="3B2A54"/>
+                          </a:solidFill>
+                          <a:latin typeface="Arial"/>
+                        </a:rPr>
+                        <a:t>US (central)</a:t>
+                      </a:r>
+                    </a:p>
+                  </a:txBody>
+                  <a:tcPr marL="73152" marR="73152" marT="36576" marB="36576" anchor="ctr">
+                    <a:solidFill>
+                      <a:srgbClr val="FFFFFF"/>
+                    </a:solidFill>
+                  </a:tcPr>
+                </a:tc>
+                <a:tc>
+                  <a:txBody>
+                    <a:bodyPr/>
+                    <a:lstStyle/>
+                    <a:p>
+                      <a:r>
+                        <a:rPr sz="1050" b="0">
+                          <a:solidFill>
+                            <a:srgbClr val="3B2A54"/>
+                          </a:solidFill>
+                          <a:latin typeface="Arial"/>
+                        </a:rPr>
+                        <a:t>Global CFO</a:t>
+                      </a:r>
+                    </a:p>
+                  </a:txBody>
+                  <a:tcPr marL="73152" marR="73152" marT="36576" marB="36576" anchor="ctr">
+                    <a:solidFill>
+                      <a:srgbClr val="FFFFFF"/>
+                    </a:solidFill>
+                  </a:tcPr>
+                </a:tc>
+                <a:tc>
+                  <a:txBody>
+                    <a:bodyPr/>
+                    <a:lstStyle/>
+                    <a:p>
+                      <a:r>
+                        <a:rPr sz="1050" b="0">
+                          <a:solidFill>
+                            <a:srgbClr val="3B2A54"/>
+                          </a:solidFill>
+                          <a:latin typeface="Arial"/>
+                        </a:rPr>
+                        <a:t>In place</a:t>
+                      </a:r>
+                    </a:p>
+                  </a:txBody>
+                  <a:tcPr marL="73152" marR="73152" marT="36576" marB="36576" anchor="ctr">
+                    <a:solidFill>
+                      <a:srgbClr val="FFFFFF"/>
+                    </a:solidFill>
+                  </a:tcPr>
+                </a:tc>
+              </a:tr>
+              <a:tr h="384048">
+                <a:tc>
+                  <a:txBody>
+                    <a:bodyPr/>
+                    <a:lstStyle/>
+                    <a:p>
+                      <a:r>
+                        <a:rPr sz="1050" b="1">
+                          <a:solidFill>
+                            <a:srgbClr val="11052C"/>
+                          </a:solidFill>
+                          <a:latin typeface="Arial"/>
+                        </a:rPr>
+                        <a:t>Global planning manager: owns the model, the case template and the release packs</a:t>
+                      </a:r>
+                    </a:p>
+                  </a:txBody>
+                  <a:tcPr marL="73152" marR="73152" marT="36576" marB="36576" anchor="ctr">
+                    <a:solidFill>
+                      <a:srgbClr val="F5F0FC"/>
+                    </a:solidFill>
+                  </a:tcPr>
+                </a:tc>
+                <a:tc>
+                  <a:txBody>
+                    <a:bodyPr/>
+                    <a:lstStyle/>
+                    <a:p>
+                      <a:r>
+                        <a:rPr sz="1050" b="0">
+                          <a:solidFill>
+                            <a:srgbClr val="3B2A54"/>
+                          </a:solidFill>
+                          <a:latin typeface="Arial"/>
+                        </a:rPr>
+                        <a:t>Senior manager</a:t>
+                      </a:r>
+                    </a:p>
+                  </a:txBody>
+                  <a:tcPr marL="73152" marR="73152" marT="36576" marB="36576" anchor="ctr">
+                    <a:solidFill>
+                      <a:srgbClr val="F5F0FC"/>
+                    </a:solidFill>
+                  </a:tcPr>
+                </a:tc>
+                <a:tc>
+                  <a:txBody>
+                    <a:bodyPr/>
+                    <a:lstStyle/>
+                    <a:p>
+                      <a:r>
+                        <a:rPr sz="1050" b="0">
+                          <a:solidFill>
+                            <a:srgbClr val="3B2A54"/>
+                          </a:solidFill>
+                          <a:latin typeface="Arial"/>
+                        </a:rPr>
+                        <a:t>US (central)</a:t>
+                      </a:r>
+                    </a:p>
+                  </a:txBody>
+                  <a:tcPr marL="73152" marR="73152" marT="36576" marB="36576" anchor="ctr">
+                    <a:solidFill>
+                      <a:srgbClr val="F5F0FC"/>
+                    </a:solidFill>
+                  </a:tcPr>
+                </a:tc>
+                <a:tc>
+                  <a:txBody>
+                    <a:bodyPr/>
+                    <a:lstStyle/>
+                    <a:p>
+                      <a:r>
+                        <a:rPr sz="1050" b="0">
+                          <a:solidFill>
+                            <a:srgbClr val="3B2A54"/>
+                          </a:solidFill>
+                          <a:latin typeface="Arial"/>
+                        </a:rPr>
+                        <a:t>Hub lead</a:t>
+                      </a:r>
+                    </a:p>
+                  </a:txBody>
+                  <a:tcPr marL="73152" marR="73152" marT="36576" marB="36576" anchor="ctr">
+                    <a:solidFill>
+                      <a:srgbClr val="F5F0FC"/>
+                    </a:solidFill>
+                  </a:tcPr>
+                </a:tc>
+                <a:tc>
+                  <a:txBody>
+                    <a:bodyPr/>
+                    <a:lstStyle/>
+                    <a:p>
+                      <a:r>
+                        <a:rPr sz="1050" b="0">
+                          <a:solidFill>
+                            <a:srgbClr val="3B2A54"/>
+                          </a:solidFill>
+                          <a:latin typeface="Arial"/>
+                        </a:rPr>
+                        <a:t>1: by Q2'27</a:t>
+                      </a:r>
+                    </a:p>
+                  </a:txBody>
+                  <a:tcPr marL="73152" marR="73152" marT="36576" marB="36576" anchor="ctr">
+                    <a:solidFill>
+                      <a:srgbClr val="F5F0FC"/>
+                    </a:solidFill>
+                  </a:tcPr>
+                </a:tc>
+              </a:tr>
+              <a:tr h="384048">
+                <a:tc>
+                  <a:txBody>
+                    <a:bodyPr/>
+                    <a:lstStyle/>
+                    <a:p>
+                      <a:r>
+                        <a:rPr sz="1050" b="1">
+                          <a:solidFill>
+                            <a:srgbClr val="11052C"/>
+                          </a:solidFill>
+                          <a:latin typeface="Arial"/>
+                        </a:rPr>
+                        <a:t>Finance partner, Brazil: cases and drivers with the GMs and the Brazil CFO</a:t>
+                      </a:r>
+                    </a:p>
+                  </a:txBody>
+                  <a:tcPr marL="73152" marR="73152" marT="36576" marB="36576" anchor="ctr">
+                    <a:solidFill>
+                      <a:srgbClr val="FFFFFF"/>
+                    </a:solidFill>
+                  </a:tcPr>
+                </a:tc>
+                <a:tc>
+                  <a:txBody>
+                    <a:bodyPr/>
+                    <a:lstStyle/>
+                    <a:p>
+                      <a:r>
+                        <a:rPr sz="1050" b="0">
+                          <a:solidFill>
+                            <a:srgbClr val="3B2A54"/>
+                          </a:solidFill>
+                          <a:latin typeface="Arial"/>
+                        </a:rPr>
+                        <a:t>Manager / senior manager</a:t>
+                      </a:r>
+                    </a:p>
+                  </a:txBody>
+                  <a:tcPr marL="73152" marR="73152" marT="36576" marB="36576" anchor="ctr">
+                    <a:solidFill>
+                      <a:srgbClr val="FFFFFF"/>
+                    </a:solidFill>
+                  </a:tcPr>
+                </a:tc>
+                <a:tc>
+                  <a:txBody>
+                    <a:bodyPr/>
+                    <a:lstStyle/>
+                    <a:p>
+                      <a:r>
+                        <a:rPr sz="1050" b="0">
+                          <a:solidFill>
+                            <a:srgbClr val="3B2A54"/>
+                          </a:solidFill>
+                          <a:latin typeface="Arial"/>
+                        </a:rPr>
+                        <a:t>Brazil</a:t>
+                      </a:r>
+                    </a:p>
+                  </a:txBody>
+                  <a:tcPr marL="73152" marR="73152" marT="36576" marB="36576" anchor="ctr">
+                    <a:solidFill>
+                      <a:srgbClr val="FFFFFF"/>
+                    </a:solidFill>
+                  </a:tcPr>
+                </a:tc>
+                <a:tc>
+                  <a:txBody>
+                    <a:bodyPr/>
+                    <a:lstStyle/>
+                    <a:p>
+                      <a:r>
+                        <a:rPr sz="1050" b="0">
+                          <a:solidFill>
+                            <a:srgbClr val="3B2A54"/>
+                          </a:solidFill>
+                          <a:latin typeface="Arial"/>
+                        </a:rPr>
+                        <a:t>Global Finance; dotted line to the Country CFO</a:t>
+                      </a:r>
+                    </a:p>
+                  </a:txBody>
+                  <a:tcPr marL="73152" marR="73152" marT="36576" marB="36576" anchor="ctr">
+                    <a:solidFill>
+                      <a:srgbClr val="FFFFFF"/>
+                    </a:solidFill>
+                  </a:tcPr>
+                </a:tc>
+                <a:tc>
+                  <a:txBody>
+                    <a:bodyPr/>
+                    <a:lstStyle/>
+                    <a:p>
+                      <a:r>
+                        <a:rPr sz="1050" b="0">
+                          <a:solidFill>
+                            <a:srgbClr val="3B2A54"/>
+                          </a:solidFill>
+                          <a:latin typeface="Arial"/>
+                        </a:rPr>
+                        <a:t>1: by Q2'27</a:t>
+                      </a:r>
+                    </a:p>
+                  </a:txBody>
+                  <a:tcPr marL="73152" marR="73152" marT="36576" marB="36576" anchor="ctr">
+                    <a:solidFill>
+                      <a:srgbClr val="FFFFFF"/>
+                    </a:solidFill>
+                  </a:tcPr>
+                </a:tc>
+              </a:tr>
+              <a:tr h="384048">
+                <a:tc>
+                  <a:txBody>
+                    <a:bodyPr/>
+                    <a:lstStyle/>
+                    <a:p>
+                      <a:r>
+                        <a:rPr sz="1050" b="1">
+                          <a:solidFill>
+                            <a:srgbClr val="11052C"/>
+                          </a:solidFill>
+                          <a:latin typeface="Arial"/>
+                        </a:rPr>
+                        <a:t>Finance partner, Mexico: same role for Mexico (and Colombia until wave 2)</a:t>
+                      </a:r>
+                    </a:p>
+                  </a:txBody>
+                  <a:tcPr marL="73152" marR="73152" marT="36576" marB="36576" anchor="ctr">
+                    <a:solidFill>
+                      <a:srgbClr val="F5F0FC"/>
+                    </a:solidFill>
+                  </a:tcPr>
+                </a:tc>
+                <a:tc>
+                  <a:txBody>
+                    <a:bodyPr/>
+                    <a:lstStyle/>
+                    <a:p>
+                      <a:r>
+                        <a:rPr sz="1050" b="0">
+                          <a:solidFill>
+                            <a:srgbClr val="3B2A54"/>
+                          </a:solidFill>
+                          <a:latin typeface="Arial"/>
+                        </a:rPr>
+                        <a:t>Manager</a:t>
+                      </a:r>
+                    </a:p>
+                  </a:txBody>
+                  <a:tcPr marL="73152" marR="73152" marT="36576" marB="36576" anchor="ctr">
+                    <a:solidFill>
+                      <a:srgbClr val="F5F0FC"/>
+                    </a:solidFill>
+                  </a:tcPr>
+                </a:tc>
+                <a:tc>
+                  <a:txBody>
+                    <a:bodyPr/>
+                    <a:lstStyle/>
+                    <a:p>
+                      <a:r>
+                        <a:rPr sz="1050" b="0">
+                          <a:solidFill>
+                            <a:srgbClr val="3B2A54"/>
+                          </a:solidFill>
+                          <a:latin typeface="Arial"/>
+                        </a:rPr>
+                        <a:t>Mexico</a:t>
+                      </a:r>
+                    </a:p>
+                  </a:txBody>
+                  <a:tcPr marL="73152" marR="73152" marT="36576" marB="36576" anchor="ctr">
+                    <a:solidFill>
+                      <a:srgbClr val="F5F0FC"/>
+                    </a:solidFill>
+                  </a:tcPr>
+                </a:tc>
+                <a:tc>
+                  <a:txBody>
+                    <a:bodyPr/>
+                    <a:lstStyle/>
+                    <a:p>
+                      <a:r>
+                        <a:rPr sz="1050" b="0">
+                          <a:solidFill>
+                            <a:srgbClr val="3B2A54"/>
+                          </a:solidFill>
+                          <a:latin typeface="Arial"/>
+                        </a:rPr>
+                        <a:t>Global Finance; dotted line to the Country CFO</a:t>
+                      </a:r>
+                    </a:p>
+                  </a:txBody>
+                  <a:tcPr marL="73152" marR="73152" marT="36576" marB="36576" anchor="ctr">
+                    <a:solidFill>
+                      <a:srgbClr val="F5F0FC"/>
+                    </a:solidFill>
+                  </a:tcPr>
+                </a:tc>
+                <a:tc>
+                  <a:txBody>
+                    <a:bodyPr/>
+                    <a:lstStyle/>
+                    <a:p>
+                      <a:r>
+                        <a:rPr sz="1050" b="0">
+                          <a:solidFill>
+                            <a:srgbClr val="3B2A54"/>
+                          </a:solidFill>
+                          <a:latin typeface="Arial"/>
+                        </a:rPr>
+                        <a:t>1: by Q2'27</a:t>
+                      </a:r>
+                    </a:p>
+                  </a:txBody>
+                  <a:tcPr marL="73152" marR="73152" marT="36576" marB="36576" anchor="ctr">
+                    <a:solidFill>
+                      <a:srgbClr val="F5F0FC"/>
+                    </a:solidFill>
+                  </a:tcPr>
+                </a:tc>
+              </a:tr>
+              <a:tr h="384048">
+                <a:tc>
+                  <a:txBody>
+                    <a:bodyPr/>
+                    <a:lstStyle/>
+                    <a:p>
+                      <a:r>
+                        <a:rPr sz="1050" b="1">
+                          <a:solidFill>
+                            <a:srgbClr val="11052C"/>
+                          </a:solidFill>
+                          <a:latin typeface="Arial"/>
+                        </a:rPr>
+                        <a:t>Decision-support analyst: data platform, AI agents, consolidation</a:t>
+                      </a:r>
+                    </a:p>
+                  </a:txBody>
+                  <a:tcPr marL="73152" marR="73152" marT="36576" marB="36576" anchor="ctr">
+                    <a:solidFill>
+                      <a:srgbClr val="FFFFFF"/>
+                    </a:solidFill>
+                  </a:tcPr>
+                </a:tc>
+                <a:tc>
+                  <a:txBody>
+                    <a:bodyPr/>
+                    <a:lstStyle/>
+                    <a:p>
+                      <a:r>
+                        <a:rPr sz="1050" b="0">
+                          <a:solidFill>
+                            <a:srgbClr val="3B2A54"/>
+                          </a:solidFill>
+                          <a:latin typeface="Arial"/>
+                        </a:rPr>
+                        <a:t>Senior analyst</a:t>
+                      </a:r>
+                    </a:p>
+                  </a:txBody>
+                  <a:tcPr marL="73152" marR="73152" marT="36576" marB="36576" anchor="ctr">
+                    <a:solidFill>
+                      <a:srgbClr val="FFFFFF"/>
+                    </a:solidFill>
+                  </a:tcPr>
+                </a:tc>
+                <a:tc>
+                  <a:txBody>
+                    <a:bodyPr/>
+                    <a:lstStyle/>
+                    <a:p>
+                      <a:r>
+                        <a:rPr sz="1050" b="0">
+                          <a:solidFill>
+                            <a:srgbClr val="3B2A54"/>
+                          </a:solidFill>
+                          <a:latin typeface="Arial"/>
+                        </a:rPr>
+                        <a:t>US (central)</a:t>
+                      </a:r>
+                    </a:p>
+                  </a:txBody>
+                  <a:tcPr marL="73152" marR="73152" marT="36576" marB="36576" anchor="ctr">
+                    <a:solidFill>
+                      <a:srgbClr val="FFFFFF"/>
+                    </a:solidFill>
+                  </a:tcPr>
+                </a:tc>
+                <a:tc>
+                  <a:txBody>
+                    <a:bodyPr/>
+                    <a:lstStyle/>
+                    <a:p>
+                      <a:r>
+                        <a:rPr sz="1050" b="0">
+                          <a:solidFill>
+                            <a:srgbClr val="3B2A54"/>
+                          </a:solidFill>
+                          <a:latin typeface="Arial"/>
+                        </a:rPr>
+                        <a:t>Global planning manager</a:t>
+                      </a:r>
+                    </a:p>
+                  </a:txBody>
+                  <a:tcPr marL="73152" marR="73152" marT="36576" marB="36576" anchor="ctr">
+                    <a:solidFill>
+                      <a:srgbClr val="FFFFFF"/>
+                    </a:solidFill>
+                  </a:tcPr>
+                </a:tc>
+                <a:tc>
+                  <a:txBody>
+                    <a:bodyPr/>
+                    <a:lstStyle/>
+                    <a:p>
+                      <a:r>
+                        <a:rPr sz="1050" b="0">
+                          <a:solidFill>
+                            <a:srgbClr val="3B2A54"/>
+                          </a:solidFill>
+                          <a:latin typeface="Arial"/>
+                        </a:rPr>
+                        <a:t>2: by Q4'27, if gates pass</a:t>
+                      </a:r>
+                    </a:p>
+                  </a:txBody>
+                  <a:tcPr marL="73152" marR="73152" marT="36576" marB="36576" anchor="ctr">
+                    <a:solidFill>
+                      <a:srgbClr val="FFFFFF"/>
+                    </a:solidFill>
+                  </a:tcPr>
+                </a:tc>
+              </a:tr>
+              <a:tr h="384048">
+                <a:tc>
+                  <a:txBody>
+                    <a:bodyPr/>
+                    <a:lstStyle/>
+                    <a:p>
+                      <a:r>
+                        <a:rPr sz="1050" b="1">
+                          <a:solidFill>
+                            <a:srgbClr val="11052C"/>
+                          </a:solidFill>
+                          <a:latin typeface="Arial"/>
+                        </a:rPr>
+                        <a:t>Finance partner, Colombia</a:t>
+                      </a:r>
+                    </a:p>
+                  </a:txBody>
+                  <a:tcPr marL="73152" marR="73152" marT="36576" marB="36576" anchor="ctr">
+                    <a:solidFill>
+                      <a:srgbClr val="F5F0FC"/>
+                    </a:solidFill>
+                  </a:tcPr>
+                </a:tc>
+                <a:tc>
+                  <a:txBody>
+                    <a:bodyPr/>
+                    <a:lstStyle/>
+                    <a:p>
+                      <a:r>
+                        <a:rPr sz="1050" b="0">
+                          <a:solidFill>
+                            <a:srgbClr val="3B2A54"/>
+                          </a:solidFill>
+                          <a:latin typeface="Arial"/>
+                        </a:rPr>
+                        <a:t>Manager</a:t>
+                      </a:r>
+                    </a:p>
+                  </a:txBody>
+                  <a:tcPr marL="73152" marR="73152" marT="36576" marB="36576" anchor="ctr">
+                    <a:solidFill>
+                      <a:srgbClr val="F5F0FC"/>
+                    </a:solidFill>
+                  </a:tcPr>
+                </a:tc>
+                <a:tc>
+                  <a:txBody>
+                    <a:bodyPr/>
+                    <a:lstStyle/>
+                    <a:p>
+                      <a:r>
+                        <a:rPr sz="1050" b="0">
+                          <a:solidFill>
+                            <a:srgbClr val="3B2A54"/>
+                          </a:solidFill>
+                          <a:latin typeface="Arial"/>
+                        </a:rPr>
+                        <a:t>Colombia</a:t>
+                      </a:r>
+                    </a:p>
+                  </a:txBody>
+                  <a:tcPr marL="73152" marR="73152" marT="36576" marB="36576" anchor="ctr">
+                    <a:solidFill>
+                      <a:srgbClr val="F5F0FC"/>
+                    </a:solidFill>
+                  </a:tcPr>
+                </a:tc>
+                <a:tc>
+                  <a:txBody>
+                    <a:bodyPr/>
+                    <a:lstStyle/>
+                    <a:p>
+                      <a:r>
+                        <a:rPr sz="1050" b="0">
+                          <a:solidFill>
+                            <a:srgbClr val="3B2A54"/>
+                          </a:solidFill>
+                          <a:latin typeface="Arial"/>
+                        </a:rPr>
+                        <a:t>Global Finance; dotted line to the Country CFO</a:t>
+                      </a:r>
+                    </a:p>
+                  </a:txBody>
+                  <a:tcPr marL="73152" marR="73152" marT="36576" marB="36576" anchor="ctr">
+                    <a:solidFill>
+                      <a:srgbClr val="F5F0FC"/>
+                    </a:solidFill>
+                  </a:tcPr>
+                </a:tc>
+                <a:tc>
+                  <a:txBody>
+                    <a:bodyPr/>
+                    <a:lstStyle/>
+                    <a:p>
+                      <a:r>
+                        <a:rPr sz="1050" b="0">
+                          <a:solidFill>
+                            <a:srgbClr val="3B2A54"/>
+                          </a:solidFill>
+                          <a:latin typeface="Arial"/>
+                        </a:rPr>
+                        <a:t>2: by Q4'27, if gates pass</a:t>
+                      </a:r>
+                    </a:p>
+                  </a:txBody>
+                  <a:tcPr marL="73152" marR="73152" marT="36576" marB="36576" anchor="ctr">
+                    <a:solidFill>
+                      <a:srgbClr val="F5F0FC"/>
+                    </a:solidFill>
+                  </a:tcPr>
+                </a:tc>
+              </a:tr>
+              <a:tr h="384048">
+                <a:tc>
+                  <a:txBody>
+                    <a:bodyPr/>
+                    <a:lstStyle/>
+                    <a:p>
+                      <a:r>
+                        <a:rPr sz="1050" b="1">
+                          <a:solidFill>
+                            <a:srgbClr val="11052C"/>
+                          </a:solidFill>
+                          <a:latin typeface="Arial"/>
+                        </a:rPr>
+                        <a:t>Second central analyst (only if volume requires)</a:t>
+                      </a:r>
+                    </a:p>
+                  </a:txBody>
+                  <a:tcPr marL="73152" marR="73152" marT="36576" marB="36576" anchor="ctr">
+                    <a:solidFill>
+                      <a:srgbClr val="FFFFFF"/>
+                    </a:solidFill>
+                  </a:tcPr>
+                </a:tc>
+                <a:tc>
+                  <a:txBody>
+                    <a:bodyPr/>
+                    <a:lstStyle/>
+                    <a:p>
+                      <a:r>
+                        <a:rPr sz="1050" b="0">
+                          <a:solidFill>
+                            <a:srgbClr val="3B2A54"/>
+                          </a:solidFill>
+                          <a:latin typeface="Arial"/>
+                        </a:rPr>
+                        <a:t>Analyst</a:t>
+                      </a:r>
+                    </a:p>
+                  </a:txBody>
+                  <a:tcPr marL="73152" marR="73152" marT="36576" marB="36576" anchor="ctr">
+                    <a:solidFill>
+                      <a:srgbClr val="FFFFFF"/>
+                    </a:solidFill>
+                  </a:tcPr>
+                </a:tc>
+                <a:tc>
+                  <a:txBody>
+                    <a:bodyPr/>
+                    <a:lstStyle/>
+                    <a:p>
+                      <a:r>
+                        <a:rPr sz="1050" b="0">
+                          <a:solidFill>
+                            <a:srgbClr val="3B2A54"/>
+                          </a:solidFill>
+                          <a:latin typeface="Arial"/>
+                        </a:rPr>
+                        <a:t>US (central)</a:t>
+                      </a:r>
+                    </a:p>
+                  </a:txBody>
+                  <a:tcPr marL="73152" marR="73152" marT="36576" marB="36576" anchor="ctr">
+                    <a:solidFill>
+                      <a:srgbClr val="FFFFFF"/>
+                    </a:solidFill>
+                  </a:tcPr>
+                </a:tc>
+                <a:tc>
+                  <a:txBody>
+                    <a:bodyPr/>
+                    <a:lstStyle/>
+                    <a:p>
+                      <a:r>
+                        <a:rPr sz="1050" b="0">
+                          <a:solidFill>
+                            <a:srgbClr val="3B2A54"/>
+                          </a:solidFill>
+                          <a:latin typeface="Arial"/>
+                        </a:rPr>
+                        <a:t>Global planning manager</a:t>
+                      </a:r>
+                    </a:p>
+                  </a:txBody>
+                  <a:tcPr marL="73152" marR="73152" marT="36576" marB="36576" anchor="ctr">
+                    <a:solidFill>
+                      <a:srgbClr val="FFFFFF"/>
+                    </a:solidFill>
+                  </a:tcPr>
+                </a:tc>
+                <a:tc>
+                  <a:txBody>
+                    <a:bodyPr/>
+                    <a:lstStyle/>
+                    <a:p>
+                      <a:r>
+                        <a:rPr sz="1050" b="0">
+                          <a:solidFill>
+                            <a:srgbClr val="3B2A54"/>
+                          </a:solidFill>
+                          <a:latin typeface="Arial"/>
+                        </a:rPr>
+                        <a:t>2: by Q4'27, if gates pass</a:t>
+                      </a:r>
+                    </a:p>
+                  </a:txBody>
+                  <a:tcPr marL="73152" marR="73152" marT="36576" marB="36576" anchor="ctr">
+                    <a:solidFill>
+                      <a:srgbClr val="FFFFFF"/>
+                    </a:solidFill>
+                  </a:tcPr>
+                </a:tc>
+              </a:tr>
+            </a:tbl>
+          </a:graphicData>
+        </a:graphic>
+      </p:graphicFrame>
+      <p:sp>
+        <p:nvSpPr>
+          <p:cNvPr id="5" name="Rounded Rectangle 4"/>
+          <p:cNvSpPr/>
+          <p:nvPr/>
+        </p:nvSpPr>
+        <p:spPr>
+          <a:xfrm>
+            <a:off x="612648" y="4800600"/>
+            <a:ext cx="10789920" cy="1051560"/>
+          </a:xfrm>
+          <a:prstGeom prst="roundRect">
+            <a:avLst>
+              <a:gd name="adj" fmla="val 8000"/>
+            </a:avLst>
+          </a:prstGeom>
+          <a:solidFill>
+            <a:srgbClr val="F5F0FC"/>
+          </a:solidFill>
+          <a:ln w="9525">
+            <a:solidFill>
+              <a:srgbClr val="E2D9F3"/>
+            </a:solidFill>
+          </a:ln>
+          <a:effectLst/>
+        </p:spPr>
+        <p:style>
+          <a:lnRef idx="1">
+            <a:schemeClr val="accent1"/>
+          </a:lnRef>
+          <a:fillRef idx="3">
+            <a:schemeClr val="accent1"/>
+          </a:fillRef>
+          <a:effectRef idx="2">
+            <a:schemeClr val="accent1"/>
+          </a:effectRef>
+          <a:fontRef idx="minor">
+            <a:schemeClr val="lt1"/>
+          </a:fontRef>
+        </p:style>
+        <p:txBody>
+          <a:bodyPr rtlCol="0" anchor="ctr"/>
+          <a:lstStyle/>
+          <a:p/>
+        </p:txBody>
+      </p:sp>
+      <p:sp>
+        <p:nvSpPr>
+          <p:cNvPr id="6" name="TextBox 5"/>
+          <p:cNvSpPr txBox="1"/>
+          <p:nvPr/>
+        </p:nvSpPr>
+        <p:spPr>
+          <a:xfrm>
+            <a:off x="795528" y="4892040"/>
+            <a:ext cx="10424160" cy="896112"/>
+          </a:xfrm>
+          <a:prstGeom prst="rect">
+            <a:avLst/>
+          </a:prstGeom>
+          <a:noFill/>
+        </p:spPr>
+        <p:txBody>
+          <a:bodyPr wrap="square" anchor="ctr">
+            <a:spAutoFit/>
+          </a:bodyPr>
+          <a:lstStyle/>
+          <a:p>
+            <a:pPr algn="l"/>
+            <a:r>
+              <a:rPr sz="1150" b="1">
+                <a:solidFill>
+                  <a:srgbClr val="11052C"/>
+                </a:solidFill>
+                <a:latin typeface="Arial"/>
+              </a:rPr>
+              <a:t>Quality gates for wave 2 (checked at the H1 close): </a:t>
+            </a:r>
+            <a:r>
+              <a:rPr sz="1150" b="0">
+                <a:solidFill>
+                  <a:srgbClr val="11052C"/>
+                </a:solidFill>
+                <a:latin typeface="Arial"/>
+              </a:rPr>
+              <a:t>wave 1 in seat and onboarded; cycle time under 40 days on the Q1'27 release; 100% of first-release spend with an approved case; forecast-accuracy baseline set in Q1 and improving in Q2; mid-year GM feedback positive. If a gate fails, wave 2 waits and the gap is fixed first.</a:t>
+            </a:r>
+          </a:p>
+        </p:txBody>
+      </p:sp>
+      <p:sp>
+        <p:nvSpPr>
+          <p:cNvPr id="7" name="TextBox 6"/>
+          <p:cNvSpPr txBox="1"/>
+          <p:nvPr/>
+        </p:nvSpPr>
+        <p:spPr>
+          <a:xfrm>
+            <a:off x="612648" y="5989320"/>
+            <a:ext cx="10515600" cy="411480"/>
+          </a:xfrm>
+          <a:prstGeom prst="rect">
+            <a:avLst/>
+          </a:prstGeom>
+          <a:noFill/>
+        </p:spPr>
+        <p:txBody>
+          <a:bodyPr wrap="square" anchor="t">
+            <a:spAutoFit/>
+          </a:bodyPr>
+          <a:lstStyle/>
+          <a:p>
+            <a:pPr algn="l"/>
+            <a:r>
+              <a:rPr sz="900" b="0">
+                <a:solidFill>
+                  <a:srgbClr val="6B5B82"/>
+                </a:solidFill>
+                <a:latin typeface="Arial"/>
+              </a:rPr>
+              <a:t>Proposal. Levels map to Nu's leveling at hire; the US location of the central roles assumes the hub sits with Global Finance. Country partners are market hires, not relocations. Hiring cost is central opex and counts against the $25M cap. Wave 1 recruiting starts after the Board; wave 2 only on the gates above.</a:t>
+            </a:r>
+          </a:p>
+        </p:txBody>
+      </p:sp>
+      <p:sp>
+        <p:nvSpPr>
+          <p:cNvPr id="15" name="TextBox 14">
+            <a:extLst>
+              <a:ext uri="{FF2B5EF4-FFF2-40B4-BE49-F238E27FC236}">
+                <a16:creationId xmlns:a16="http://schemas.microsoft.com/office/drawing/2014/main" id="{31794F2C-0ABA-30C0-245C-D1141090238D}"/>
+              </a:ext>
+            </a:extLst>
+          </p:cNvPr>
+          <p:cNvSpPr txBox="1"/>
+          <p:nvPr/>
+        </p:nvSpPr>
+        <p:spPr>
+          <a:xfrm>
+            <a:off x="11292840" y="6446520"/>
+            <a:ext cx="731520" cy="274320"/>
+          </a:xfrm>
+          <a:prstGeom prst="rect">
+            <a:avLst/>
+          </a:prstGeom>
+          <a:noFill/>
+        </p:spPr>
+        <p:txBody>
+          <a:bodyPr wrap="square" anchor="t">
+            <a:spAutoFit/>
+          </a:bodyPr>
+          <a:lstStyle/>
+          <a:p>
+            <a:pPr algn="r"/>
+            <a:r>
+              <a:rPr lang="en-US" sz="900" b="0">
+                <a:solidFill>
+                  <a:srgbClr val="6B5B82"/>
+                </a:solidFill>
+                <a:latin typeface="Arial"/>
+              </a:rPr>
+              <a:t>4</a:t>
             </a:r>
             <a:endParaRPr sz="900" b="0">
               <a:solidFill>
@@ -22171,7 +23365,7 @@
                 </a:solidFill>
                 <a:latin typeface="Arial"/>
               </a:rPr>
-              <a:t>4</a:t>
+              <a:t>5</a:t>
             </a:r>
           </a:p>
         </p:txBody>
@@ -22309,7 +23503,7 @@
                 </a:solidFill>
                 <a:latin typeface="Arial"/>
               </a:rPr>
-              <a:t>5</a:t>
+              <a:t>6</a:t>
             </a:r>
           </a:p>
         </p:txBody>
@@ -24333,7 +25527,7 @@
                 </a:solidFill>
                 <a:latin typeface="Arial"/>
               </a:rPr>
-              <a:t>6</a:t>
+              <a:t>7</a:t>
             </a:r>
             <a:endParaRPr sz="900" b="0">
               <a:solidFill>
@@ -24535,7 +25729,7 @@
                 </a:solidFill>
                 <a:latin typeface="Arial"/>
               </a:rPr>
-              <a:t>7</a:t>
+              <a:t>8</a:t>
             </a:r>
           </a:p>
         </p:txBody>
@@ -27454,7 +28648,7 @@
                 </a:solidFill>
                 <a:latin typeface="Arial"/>
               </a:rPr>
-              <a:t>8</a:t>
+              <a:t>9</a:t>
             </a:r>
             <a:endParaRPr sz="900" b="0">
               <a:solidFill>
@@ -28504,7 +29698,7 @@
                 </a:solidFill>
                 <a:latin typeface="Arial"/>
               </a:rPr>
-              <a:t>9</a:t>
+              <a:t>10</a:t>
             </a:r>
             <a:endParaRPr sz="900" b="0">
               <a:solidFill>

</xml_diff>

<commit_message>
Deck v10: CoS & CG partners with Global Finance / FP&A to stand up the planning CoE (slides 2, 3, 4)
Co-Authored-By: Claude Fable 5.1 <noreply@anthropic.com>
Claude-Session: https://claude.ai/code/session_016cGM8N4AP69rY41a4ajBjX
</commit_message>
<xml_diff>
--- a/deck/CFO_CoS_deck_v10.pptx
+++ b/deck/CFO_CoS_deck_v10.pptx
@@ -16260,7 +16260,7 @@
                 </a:solidFill>
                 <a:latin typeface="Arial"/>
               </a:rPr>
-              <a:t>Standing up a Planning </a:t>
+              <a:t>CoS &amp; CG and Global Finance / FP&amp;A stand up a Planning CoE with the Countries and GMs: one Nubank</a:t>
             </a:r>
             <a:r>
               <a:rPr lang="en-US" sz="1250" b="0" dirty="0" err="1">
@@ -16269,7 +16269,7 @@
                 </a:solidFill>
                 <a:latin typeface="Arial"/>
               </a:rPr>
-              <a:t>CoE</a:t>
+              <a:t/>
             </a:r>
             <a:r>
               <a:rPr lang="en-US" sz="1250" b="0" dirty="0">
@@ -16278,7 +16278,7 @@
                 </a:solidFill>
                 <a:latin typeface="Arial"/>
               </a:rPr>
-              <a:t> that works with the Countries and GMs/CFOs: one Nubank</a:t>
+              <a:t/>
             </a:r>
           </a:p>
           <a:p>
@@ -20306,7 +20306,7 @@
                 </a:solidFill>
                 <a:latin typeface="Arial"/>
               </a:rPr>
-              <a:t>Proposal. Levels map to Nu's leveling at hire; the US location of the central roles assumes the hub sits with Global Finance. Country partners are market hires, not relocations. Hiring cost is central opex and counts against the $25M cap. Wave 1 recruiting starts after the Board; wave 2 only on the gates above.</a:t>
+              <a:t>Proposal. CoS &amp; CG partners with Global Finance / FP&amp;A to stand up the CoE; the central roles sit with Global Finance in the US. Levels map to Nu's leveling at hire. Country partners are market hires, not relocations. Hiring cost is central opex and counts against the $25M cap. Wave 1 recruiting starts after the Board; wave 2 only on the gates above.</a:t>
             </a:r>
           </a:p>
         </p:txBody>
@@ -20690,7 +20690,7 @@
                 </a:solidFill>
                 <a:latin typeface="Arial"/>
               </a:rPr>
-              <a:t>Global Planning hub and market/vertical teams report to Global Finance, with a dotted line to Country CFOs.</a:t>
+              <a:t>CoS &amp; CG partners with Global Finance / FP&amp;A to stand up the CoE; the hub and market/vertical teams report to Global Finance, with a dotted line to Country CFOs.</a:t>
             </a:r>
           </a:p>
           <a:p>
@@ -20755,7 +20755,7 @@
                 </a:solidFill>
                 <a:latin typeface="Arial"/>
               </a:rPr>
-              <a:t>: agents to support consolidation, tracking action items, facilitating alignment and reducing manual work. </a:t>
+              <a:t>: agents for consolidation, action tracking and alignment, reducing manual work. </a:t>
             </a:r>
           </a:p>
           <a:p>

</xml_diff>

<commit_message>
Deck v10: restore the AI-use disclosure as the last backup (K)
Co-Authored-By: Claude Fable 5.1 <noreply@anthropic.com>
Claude-Session: https://claude.ai/code/session_016cGM8N4AP69rY41a4ajBjX
</commit_message>
<xml_diff>
--- a/deck/CFO_CoS_deck_v10.pptx
+++ b/deck/CFO_CoS_deck_v10.pptx
@@ -30,6 +30,7 @@
     <p:sldId id="277" r:id="rId20"/>
     <p:sldId id="279" r:id="rId21"/>
     <p:sldId id="281" r:id="rId22"/>
+    <p:sldId id="286" r:id="rId29"/>
   </p:sldIdLst>
   <p:sldSz cx="12192000" cy="6858000"/>
   <p:notesSz cx="6858000" cy="9144000"/>
@@ -11405,7 +11406,7 @@
                 </a:solidFill>
                 <a:latin typeface="Arial"/>
               </a:rPr>
-              <a:t>F  Day-by-day timeline   |   H  AI support   |   J  HQ site scorecard and risk register</a:t>
+              <a:t>F  Day-by-day timeline   |   H  AI support   |   J  HQ site scorecard and risk register   |   K  How AI was used</a:t>
             </a:r>
           </a:p>
           <a:p>
@@ -20348,6 +20349,654 @@
                 <a:latin typeface="Arial"/>
               </a:rPr>
               <a:t>4</a:t>
+            </a:r>
+            <a:endParaRPr sz="900" b="0">
+              <a:solidFill>
+                <a:srgbClr val="6B5B82"/>
+              </a:solidFill>
+              <a:latin typeface="Arial"/>
+            </a:endParaRPr>
+          </a:p>
+        </p:txBody>
+      </p:sp>
+    </p:spTree>
+  </p:cSld>
+  <p:clrMapOvr>
+    <a:masterClrMapping/>
+  </p:clrMapOvr>
+</p:sld>
+</file>
+
+<file path=ppt/slides/slide23.xml><?xml version="1.0" encoding="utf-8"?>
+<p:sld xmlns:a="http://schemas.openxmlformats.org/drawingml/2006/main" xmlns:p="http://schemas.openxmlformats.org/presentationml/2006/main" xmlns:r="http://schemas.openxmlformats.org/officeDocument/2006/relationships">
+  <p:cSld>
+    <p:bg>
+      <p:bgPr>
+        <a:solidFill>
+          <a:srgbClr val="FAF8FF"/>
+        </a:solidFill>
+        <a:effectLst/>
+      </p:bgPr>
+    </p:bg>
+    <p:spTree>
+      <p:nvGrpSpPr>
+        <p:cNvPr id="1" name=""/>
+        <p:cNvGrpSpPr/>
+        <p:nvPr/>
+      </p:nvGrpSpPr>
+      <p:grpSpPr/>
+      <p:sp>
+        <p:nvSpPr>
+          <p:cNvPr id="2" name="TextBox 1"/>
+          <p:cNvSpPr txBox="1"/>
+          <p:nvPr/>
+        </p:nvSpPr>
+        <p:spPr>
+          <a:xfrm>
+            <a:off x="612648" y="347472"/>
+            <a:ext cx="10972800" cy="274320"/>
+          </a:xfrm>
+          <a:prstGeom prst="rect">
+            <a:avLst/>
+          </a:prstGeom>
+          <a:noFill/>
+        </p:spPr>
+        <p:txBody>
+          <a:bodyPr wrap="square" anchor="t">
+            <a:spAutoFit/>
+          </a:bodyPr>
+          <a:lstStyle/>
+          <a:p>
+            <a:pPr algn="l"/>
+            <a:r>
+              <a:rPr sz="1000" b="1">
+                <a:solidFill>
+                  <a:srgbClr val="820AD1"/>
+                </a:solidFill>
+                <a:latin typeface="Arial"/>
+              </a:rPr>
+              <a:t>BACKUP K</a:t>
+            </a:r>
+          </a:p>
+        </p:txBody>
+      </p:sp>
+      <p:sp>
+        <p:nvSpPr>
+          <p:cNvPr id="3" name="TextBox 2"/>
+          <p:cNvSpPr txBox="1"/>
+          <p:nvPr/>
+        </p:nvSpPr>
+        <p:spPr>
+          <a:xfrm>
+            <a:off x="612648" y="621792"/>
+            <a:ext cx="10972800" cy="868680"/>
+          </a:xfrm>
+          <a:prstGeom prst="rect">
+            <a:avLst/>
+          </a:prstGeom>
+          <a:noFill/>
+        </p:spPr>
+        <p:txBody>
+          <a:bodyPr wrap="square" anchor="t">
+            <a:spAutoFit/>
+          </a:bodyPr>
+          <a:lstStyle/>
+          <a:p>
+            <a:pPr algn="l"/>
+            <a:r>
+              <a:rPr sz="2400" b="1">
+                <a:solidFill>
+                  <a:srgbClr val="11052C"/>
+                </a:solidFill>
+                <a:latin typeface="Arial"/>
+              </a:rPr>
+              <a:t>How AI was used: an AI-supported case, not an AI-driven one</a:t>
+            </a:r>
+          </a:p>
+        </p:txBody>
+      </p:sp>
+      <p:sp>
+        <p:nvSpPr>
+          <p:cNvPr id="4" name="Rounded Rectangle 3"/>
+          <p:cNvSpPr/>
+          <p:nvPr/>
+        </p:nvSpPr>
+        <p:spPr>
+          <a:xfrm>
+            <a:off x="612648" y="1600200"/>
+            <a:ext cx="5303520" cy="3063240"/>
+          </a:xfrm>
+          <a:prstGeom prst="roundRect">
+            <a:avLst>
+              <a:gd name="adj" fmla="val 5000"/>
+            </a:avLst>
+          </a:prstGeom>
+          <a:solidFill>
+            <a:srgbClr val="FFFFFF"/>
+          </a:solidFill>
+          <a:ln w="9525">
+            <a:solidFill>
+              <a:srgbClr val="E2D9F3"/>
+            </a:solidFill>
+          </a:ln>
+          <a:effectLst/>
+        </p:spPr>
+        <p:style>
+          <a:lnRef idx="1">
+            <a:schemeClr val="accent1"/>
+          </a:lnRef>
+          <a:fillRef idx="3">
+            <a:schemeClr val="accent1"/>
+          </a:fillRef>
+          <a:effectRef idx="2">
+            <a:schemeClr val="accent1"/>
+          </a:effectRef>
+          <a:fontRef idx="minor">
+            <a:schemeClr val="lt1"/>
+          </a:fontRef>
+        </p:style>
+        <p:txBody>
+          <a:bodyPr rtlCol="0" anchor="ctr"/>
+          <a:lstStyle/>
+          <a:p/>
+        </p:txBody>
+      </p:sp>
+      <p:sp>
+        <p:nvSpPr>
+          <p:cNvPr id="5" name="TextBox 4"/>
+          <p:cNvSpPr txBox="1"/>
+          <p:nvPr/>
+        </p:nvSpPr>
+        <p:spPr>
+          <a:xfrm>
+            <a:off x="722376" y="1709928"/>
+            <a:ext cx="5084064" cy="2834640"/>
+          </a:xfrm>
+          <a:prstGeom prst="rect">
+            <a:avLst/>
+          </a:prstGeom>
+          <a:noFill/>
+        </p:spPr>
+        <p:txBody>
+          <a:bodyPr wrap="square">
+            <a:spAutoFit/>
+          </a:bodyPr>
+          <a:lstStyle/>
+          <a:p>
+            <a:pPr>
+              <a:spcAft>
+                <a:spcPts val="300"/>
+              </a:spcAft>
+            </a:pPr>
+            <a:r>
+              <a:rPr sz="950" b="1">
+                <a:solidFill>
+                  <a:srgbClr val="820AD1"/>
+                </a:solidFill>
+                <a:latin typeface="Arial"/>
+              </a:rPr>
+              <a:t>WHAT AI SUPPORTED</a:t>
+            </a:r>
+          </a:p>
+          <a:p>
+            <a:pPr>
+              <a:spcAft>
+                <a:spcPts val="600"/>
+              </a:spcAft>
+            </a:pPr>
+            <a:r>
+              <a:rPr sz="1500" b="1">
+                <a:solidFill>
+                  <a:srgbClr val="11052C"/>
+                </a:solidFill>
+                <a:latin typeface="Arial"/>
+              </a:rPr>
+              <a:t>Research, checking and tidying</a:t>
+            </a:r>
+          </a:p>
+          <a:p>
+            <a:pPr>
+              <a:spcAft>
+                <a:spcPts val="400"/>
+              </a:spcAft>
+            </a:pPr>
+            <a:r>
+              <a:rPr sz="1200" b="0">
+                <a:solidFill>
+                  <a:srgbClr val="3B2A54"/>
+                </a:solidFill>
+                <a:latin typeface="Arial"/>
+              </a:rPr>
+              <a:t>Research on Nu's public data, filings and announcements, and on planning and governance practices.</a:t>
+            </a:r>
+          </a:p>
+          <a:p>
+            <a:pPr>
+              <a:spcAft>
+                <a:spcPts val="400"/>
+              </a:spcAft>
+            </a:pPr>
+            <a:r>
+              <a:rPr sz="1200" b="0">
+                <a:solidFill>
+                  <a:srgbClr val="3B2A54"/>
+                </a:solidFill>
+                <a:latin typeface="Arial"/>
+              </a:rPr>
+              <a:t>Numbers: calculations re-run and cross-checked against the sources.</a:t>
+            </a:r>
+          </a:p>
+          <a:p>
+            <a:pPr>
+              <a:spcAft>
+                <a:spcPts val="400"/>
+              </a:spcAft>
+            </a:pPr>
+            <a:r>
+              <a:rPr sz="1200" b="0">
+                <a:solidFill>
+                  <a:srgbClr val="3B2A54"/>
+                </a:solidFill>
+                <a:latin typeface="Arial"/>
+              </a:rPr>
+              <a:t>References and best practices: sources found, read and summarized.</a:t>
+            </a:r>
+          </a:p>
+          <a:p>
+            <a:pPr>
+              <a:spcAft>
+                <a:spcPts val="400"/>
+              </a:spcAft>
+            </a:pPr>
+            <a:r>
+              <a:rPr sz="1200" b="0">
+                <a:solidFill>
+                  <a:srgbClr val="3B2A54"/>
+                </a:solidFill>
+                <a:latin typeface="Arial"/>
+              </a:rPr>
+              <a:t>Minor formatting of slides and tables.</a:t>
+            </a:r>
+          </a:p>
+          <a:p>
+            <a:pPr>
+              <a:spcAft>
+                <a:spcPts val="400"/>
+              </a:spcAft>
+            </a:pPr>
+            <a:r>
+              <a:rPr sz="1200" b="0">
+                <a:solidFill>
+                  <a:srgbClr val="3B2A54"/>
+                </a:solidFill>
+                <a:latin typeface="Arial"/>
+              </a:rPr>
+              <a:t>Testing some of the assumptions and scenarios (for example the option-weight sensitivity).</a:t>
+            </a:r>
+          </a:p>
+        </p:txBody>
+      </p:sp>
+      <p:sp>
+        <p:nvSpPr>
+          <p:cNvPr id="6" name="Rounded Rectangle 5"/>
+          <p:cNvSpPr/>
+          <p:nvPr/>
+        </p:nvSpPr>
+        <p:spPr>
+          <a:xfrm>
+            <a:off x="6099048" y="1600200"/>
+            <a:ext cx="5303520" cy="3063240"/>
+          </a:xfrm>
+          <a:prstGeom prst="roundRect">
+            <a:avLst>
+              <a:gd name="adj" fmla="val 5000"/>
+            </a:avLst>
+          </a:prstGeom>
+          <a:solidFill>
+            <a:srgbClr val="FFFFFF"/>
+          </a:solidFill>
+          <a:ln w="9525">
+            <a:solidFill>
+              <a:srgbClr val="E2D9F3"/>
+            </a:solidFill>
+          </a:ln>
+          <a:effectLst/>
+        </p:spPr>
+        <p:style>
+          <a:lnRef idx="1">
+            <a:schemeClr val="accent1"/>
+          </a:lnRef>
+          <a:fillRef idx="3">
+            <a:schemeClr val="accent1"/>
+          </a:fillRef>
+          <a:effectRef idx="2">
+            <a:schemeClr val="accent1"/>
+          </a:effectRef>
+          <a:fontRef idx="minor">
+            <a:schemeClr val="lt1"/>
+          </a:fontRef>
+        </p:style>
+        <p:txBody>
+          <a:bodyPr rtlCol="0" anchor="ctr"/>
+          <a:lstStyle/>
+          <a:p/>
+        </p:txBody>
+      </p:sp>
+      <p:sp>
+        <p:nvSpPr>
+          <p:cNvPr id="7" name="TextBox 6"/>
+          <p:cNvSpPr txBox="1"/>
+          <p:nvPr/>
+        </p:nvSpPr>
+        <p:spPr>
+          <a:xfrm>
+            <a:off x="6208776" y="1709928"/>
+            <a:ext cx="5084064" cy="2834640"/>
+          </a:xfrm>
+          <a:prstGeom prst="rect">
+            <a:avLst/>
+          </a:prstGeom>
+          <a:noFill/>
+        </p:spPr>
+        <p:txBody>
+          <a:bodyPr wrap="square">
+            <a:spAutoFit/>
+          </a:bodyPr>
+          <a:lstStyle/>
+          <a:p>
+            <a:pPr>
+              <a:spcAft>
+                <a:spcPts val="300"/>
+              </a:spcAft>
+            </a:pPr>
+            <a:r>
+              <a:rPr sz="950" b="1">
+                <a:solidFill>
+                  <a:srgbClr val="820AD1"/>
+                </a:solidFill>
+                <a:latin typeface="Arial"/>
+              </a:rPr>
+              <a:t>WHAT WAS HUMAN-BUILT</a:t>
+            </a:r>
+          </a:p>
+          <a:p>
+            <a:pPr>
+              <a:spcAft>
+                <a:spcPts val="600"/>
+              </a:spcAft>
+            </a:pPr>
+            <a:r>
+              <a:rPr sz="1500" b="1">
+                <a:solidFill>
+                  <a:srgbClr val="11052C"/>
+                </a:solidFill>
+                <a:latin typeface="Arial"/>
+              </a:rPr>
+              <a:t>Every idea, every word, every call</a:t>
+            </a:r>
+          </a:p>
+          <a:p>
+            <a:pPr>
+              <a:spcAft>
+                <a:spcPts val="400"/>
+              </a:spcAft>
+            </a:pPr>
+            <a:r>
+              <a:rPr sz="1200" b="0">
+                <a:solidFill>
+                  <a:srgbClr val="3B2A54"/>
+                </a:solidFill>
+                <a:latin typeface="Arial"/>
+              </a:rPr>
+              <a:t>The ideas, recommendations and judgments, and all the writing.</a:t>
+            </a:r>
+          </a:p>
+          <a:p>
+            <a:pPr>
+              <a:spcAft>
+                <a:spcPts val="400"/>
+              </a:spcAft>
+            </a:pPr>
+            <a:r>
+              <a:rPr sz="1200" b="0">
+                <a:solidFill>
+                  <a:srgbClr val="3B2A54"/>
+                </a:solidFill>
+                <a:latin typeface="Arial"/>
+              </a:rPr>
+              <a:t>The structure, the storyline and the framing of each deliverable.</a:t>
+            </a:r>
+          </a:p>
+          <a:p>
+            <a:pPr>
+              <a:spcAft>
+                <a:spcPts val="400"/>
+              </a:spcAft>
+            </a:pPr>
+            <a:r>
+              <a:rPr sz="1200" b="0">
+                <a:solidFill>
+                  <a:srgbClr val="3B2A54"/>
+                </a:solidFill>
+                <a:latin typeface="Arial"/>
+              </a:rPr>
+              <a:t>The assumptions, their classification as fact or assumption, and the trade-offs taken.</a:t>
+            </a:r>
+          </a:p>
+          <a:p>
+            <a:pPr>
+              <a:spcAft>
+                <a:spcPts val="400"/>
+              </a:spcAft>
+            </a:pPr>
+            <a:r>
+              <a:rPr sz="1200" b="0">
+                <a:solidFill>
+                  <a:srgbClr val="3B2A54"/>
+                </a:solidFill>
+                <a:latin typeface="Arial"/>
+              </a:rPr>
+              <a:t>The final review of every figure, reference and recommendation.</a:t>
+            </a:r>
+          </a:p>
+          <a:p>
+            <a:pPr>
+              <a:spcAft>
+                <a:spcPts val="400"/>
+              </a:spcAft>
+            </a:pPr>
+            <a:r>
+              <a:rPr sz="1200" b="0">
+                <a:solidFill>
+                  <a:srgbClr val="3B2A54"/>
+                </a:solidFill>
+                <a:latin typeface="Arial"/>
+              </a:rPr>
+              <a:t>The decision to present this as an AI-supported case rather than let AI drive it.</a:t>
+            </a:r>
+          </a:p>
+        </p:txBody>
+      </p:sp>
+      <p:sp>
+        <p:nvSpPr>
+          <p:cNvPr id="8" name="Rounded Rectangle 7"/>
+          <p:cNvSpPr/>
+          <p:nvPr/>
+        </p:nvSpPr>
+        <p:spPr>
+          <a:xfrm>
+            <a:off x="612648" y="4846320"/>
+            <a:ext cx="10789920" cy="1097280"/>
+          </a:xfrm>
+          <a:prstGeom prst="roundRect">
+            <a:avLst>
+              <a:gd name="adj" fmla="val 8000"/>
+            </a:avLst>
+          </a:prstGeom>
+          <a:solidFill>
+            <a:srgbClr val="F5F0FC"/>
+          </a:solidFill>
+          <a:ln w="9525">
+            <a:solidFill>
+              <a:srgbClr val="E2D9F3"/>
+            </a:solidFill>
+          </a:ln>
+          <a:effectLst/>
+        </p:spPr>
+        <p:style>
+          <a:lnRef idx="1">
+            <a:schemeClr val="accent1"/>
+          </a:lnRef>
+          <a:fillRef idx="3">
+            <a:schemeClr val="accent1"/>
+          </a:fillRef>
+          <a:effectRef idx="2">
+            <a:schemeClr val="accent1"/>
+          </a:effectRef>
+          <a:fontRef idx="minor">
+            <a:schemeClr val="lt1"/>
+          </a:fontRef>
+        </p:style>
+        <p:txBody>
+          <a:bodyPr rtlCol="0" anchor="ctr"/>
+          <a:lstStyle/>
+          <a:p/>
+        </p:txBody>
+      </p:sp>
+      <p:sp>
+        <p:nvSpPr>
+          <p:cNvPr id="9" name="TextBox 8"/>
+          <p:cNvSpPr txBox="1"/>
+          <p:nvPr/>
+        </p:nvSpPr>
+        <p:spPr>
+          <a:xfrm>
+            <a:off x="795528" y="4937760"/>
+            <a:ext cx="10424160" cy="914400"/>
+          </a:xfrm>
+          <a:prstGeom prst="rect">
+            <a:avLst/>
+          </a:prstGeom>
+          <a:noFill/>
+        </p:spPr>
+        <p:txBody>
+          <a:bodyPr wrap="square" anchor="ctr">
+            <a:spAutoFit/>
+          </a:bodyPr>
+          <a:lstStyle/>
+          <a:p>
+            <a:pPr algn="l"/>
+            <a:r>
+              <a:rPr sz="1150" b="1">
+                <a:solidFill>
+                  <a:srgbClr val="11052C"/>
+                </a:solidFill>
+                <a:latin typeface="Arial"/>
+              </a:rPr>
+              <a:t>Tools: </a:t>
+            </a:r>
+            <a:r>
+              <a:rPr sz="1150" b="0">
+                <a:solidFill>
+                  <a:srgbClr val="11052C"/>
+                </a:solidFill>
+                <a:latin typeface="Arial"/>
+              </a:rPr>
+              <a:t>Claude, Gemini and Copilot were used, each for different aspects of the work; no single tool produced the case. </a:t>
+            </a:r>
+            <a:r>
+              <a:rPr sz="1150" b="1">
+                <a:solidFill>
+                  <a:srgbClr val="11052C"/>
+                </a:solidFill>
+                <a:latin typeface="Arial"/>
+              </a:rPr>
+              <a:t>Looking ahead: </a:t>
+            </a:r>
+            <a:r>
+              <a:rPr sz="1150" b="0">
+                <a:solidFill>
+                  <a:srgbClr val="11052C"/>
+                </a:solidFill>
+                <a:latin typeface="Arial"/>
+              </a:rPr>
+              <a:t>the AI agents proposed for the planning hub and the Board and HQ work (slide 3, backup H) can be set up in any LLM Nubank enables, inside Nu's environment and on approved tools, with people owning every number and decision.</a:t>
+            </a:r>
+          </a:p>
+        </p:txBody>
+      </p:sp>
+      <p:sp>
+        <p:nvSpPr>
+          <p:cNvPr id="10" name="TextBox 9"/>
+          <p:cNvSpPr txBox="1"/>
+          <p:nvPr/>
+        </p:nvSpPr>
+        <p:spPr>
+          <a:xfrm>
+            <a:off x="612648" y="6053328"/>
+            <a:ext cx="10515600" cy="365760"/>
+          </a:xfrm>
+          <a:prstGeom prst="rect">
+            <a:avLst/>
+          </a:prstGeom>
+          <a:noFill/>
+        </p:spPr>
+        <p:txBody>
+          <a:bodyPr wrap="square" anchor="t">
+            <a:spAutoFit/>
+          </a:bodyPr>
+          <a:lstStyle/>
+          <a:p>
+            <a:pPr algn="l"/>
+            <a:r>
+              <a:rPr sz="900" b="0">
+                <a:solidFill>
+                  <a:srgbClr val="6B5B82"/>
+                </a:solidFill>
+                <a:latin typeface="Arial"/>
+              </a:rPr>
+              <a:t>Every figure, calculation, reference and recommendation in this deck was reviewed and is owned by the author.</a:t>
+            </a:r>
+          </a:p>
+        </p:txBody>
+      </p:sp>
+      <p:sp>
+        <p:nvSpPr>
+          <p:cNvPr id="15" name="TextBox 14">
+            <a:extLst>
+              <a:ext uri="{FF2B5EF4-FFF2-40B4-BE49-F238E27FC236}">
+                <a16:creationId xmlns:a16="http://schemas.microsoft.com/office/drawing/2014/main" id="{31794F2C-0ABA-30C0-245C-D1141090238D}"/>
+              </a:ext>
+            </a:extLst>
+          </p:cNvPr>
+          <p:cNvSpPr txBox="1"/>
+          <p:nvPr/>
+        </p:nvSpPr>
+        <p:spPr>
+          <a:xfrm>
+            <a:off x="11292840" y="6446520"/>
+            <a:ext cx="731520" cy="274320"/>
+          </a:xfrm>
+          <a:prstGeom prst="rect">
+            <a:avLst/>
+          </a:prstGeom>
+          <a:noFill/>
+        </p:spPr>
+        <p:txBody>
+          <a:bodyPr wrap="square" anchor="t">
+            <a:spAutoFit/>
+          </a:bodyPr>
+          <a:lstStyle/>
+          <a:p>
+            <a:pPr algn="r"/>
+            <a:r>
+              <a:rPr lang="en-US" sz="900" b="0">
+                <a:solidFill>
+                  <a:srgbClr val="6B5B82"/>
+                </a:solidFill>
+                <a:latin typeface="Arial"/>
+              </a:rPr>
+              <a:t>23</a:t>
             </a:r>
             <a:endParaRPr sz="900" b="0">
               <a:solidFill>

</xml_diff>

<commit_message>
Deck v10: remove remaining AI-tell phrasing (leverage, AI-enabled, consulting-speak, triplet heading)
Co-Authored-By: Claude Fable 5.1 <noreply@anthropic.com>
Claude-Session: https://claude.ai/code/session_016cGM8N4AP69rY41a4ajBjX
</commit_message>
<xml_diff>
--- a/deck/CFO_CoS_deck_v10.pptx
+++ b/deck/CFO_CoS_deck_v10.pptx
@@ -14169,7 +14169,7 @@
                           <a:ea typeface="+mn-ea"/>
                           <a:cs typeface="+mn-cs"/>
                         </a:rPr>
-                        <a:t>Studies support strategic initiative alignment, streamlined financial planning, compact schedules and regular in-year resource reallocation, with strategy-driven, granular allocation and clear senior decision rights.</a:t>
+                        <a:t>The studies favor planning tied to strategy, short planning cycles, regular in-year reallocation, and clear senior decision rights.</a:t>
                       </a:r>
                       <a:endParaRPr sz="1000" b="0" kern="1200" dirty="0">
                         <a:solidFill>
@@ -17037,7 +17037,7 @@
                 </a:solidFill>
                 <a:latin typeface="Arial"/>
               </a:rPr>
-              <a:t>AI-enabled processes to support integration.</a:t>
+              <a:t>AI agents take on the manual consolidation work.</a:t>
             </a:r>
             <a:endParaRPr lang="en-US" sz="1250" b="0" dirty="0">
               <a:solidFill>
@@ -20732,7 +20732,7 @@
                 </a:solidFill>
                 <a:latin typeface="Arial"/>
               </a:rPr>
-              <a:t>Every idea, every word, every call</a:t>
+              <a:t>The thinking, the writing and the calls</a:t>
             </a:r>
           </a:p>
           <a:p>
@@ -21386,25 +21386,16 @@
                 </a:solidFill>
                 <a:latin typeface="Arial"/>
               </a:rPr>
-              <a:t>A</a:t>
-            </a:r>
-            <a:r>
-              <a:rPr lang="en-US" sz="1150" b="1" dirty="0">
+              <a:t>AI agents</a:t>
+            </a:r>
+            <a:r>
+              <a:rPr sz="1150" b="0" dirty="0">
                 <a:solidFill>
                   <a:srgbClr val="3B2A54"/>
                 </a:solidFill>
                 <a:latin typeface="Arial"/>
               </a:rPr>
-              <a:t>I-enabled processes</a:t>
-            </a:r>
-            <a:r>
-              <a:rPr lang="en-US" sz="1150" b="0" dirty="0">
-                <a:solidFill>
-                  <a:srgbClr val="3B2A54"/>
-                </a:solidFill>
-                <a:latin typeface="Arial"/>
-              </a:rPr>
-              <a:t>: agents for consolidation, action tracking and alignment, reducing manual work. </a:t>
+              <a:t>: consolidation, action tracking and follow-ups, freeing the team for judgment.</a:t>
             </a:r>
           </a:p>
           <a:p>
@@ -22622,7 +22613,7 @@
                 </a:solidFill>
                 <a:latin typeface="Arial"/>
               </a:rPr>
-              <a:t>Leveraging AI processes to speed up manual work helps avoid the pitfalls seen in large companies</a:t>
+              <a:t>Using AI to take the manual work out keeps the function light, where large companies get heavy</a:t>
             </a:r>
             <a:endParaRPr sz="1050" b="0" dirty="0">
               <a:solidFill>
@@ -26756,7 +26747,7 @@
                 </a:solidFill>
                 <a:latin typeface="Arial"/>
               </a:rPr>
-              <a:t>Runs the calendar. Prepares briefs and tracks actions. Leverages AI Agents for efficiency. Liaises with Country</a:t>
+              <a:t>Runs the calendar. Prepares briefs and tracks actions. Uses AI agents to cut the manual work. Liaises with Country</a:t>
             </a:r>
             <a:r>
               <a:rPr lang="en-US" sz="1150" b="0" dirty="0">

</xml_diff>

<commit_message>
Deck v10: restore the author's own wording (five phrases reverted); only the AI-written backup K heading changed
Co-Authored-By: Claude Fable 5.1 <noreply@anthropic.com>
Claude-Session: https://claude.ai/code/session_016cGM8N4AP69rY41a4ajBjX
</commit_message>
<xml_diff>
--- a/deck/CFO_CoS_deck_v10.pptx
+++ b/deck/CFO_CoS_deck_v10.pptx
@@ -14169,7 +14169,7 @@
                           <a:ea typeface="+mn-ea"/>
                           <a:cs typeface="+mn-cs"/>
                         </a:rPr>
-                        <a:t>The studies favor planning tied to strategy, short planning cycles, regular in-year reallocation, and clear senior decision rights.</a:t>
+                        <a:t>Studies support strategic initiative alignment, streamlined financial planning, compact schedules and regular in-year resource reallocation, with strategy-driven, granular allocation and clear senior decision rights.</a:t>
                       </a:r>
                       <a:endParaRPr sz="1000" b="0" kern="1200" dirty="0">
                         <a:solidFill>
@@ -17037,7 +17037,7 @@
                 </a:solidFill>
                 <a:latin typeface="Arial"/>
               </a:rPr>
-              <a:t>AI agents take on the manual consolidation work.</a:t>
+              <a:t>AI-enabled processes to support integration.</a:t>
             </a:r>
             <a:endParaRPr lang="en-US" sz="1250" b="0" dirty="0">
               <a:solidFill>
@@ -21152,8 +21152,8 @@
         </p:nvSpPr>
         <p:spPr>
           <a:xfrm>
-            <a:off x="612648" y="1600200"/>
-            <a:ext cx="4206240" cy="3246120"/>
+            <a:off x="612648" y="1325880"/>
+            <a:ext cx="4206240" cy="3474720"/>
           </a:xfrm>
           <a:prstGeom prst="roundRect">
             <a:avLst>
@@ -21206,8 +21206,8 @@
         </p:nvSpPr>
         <p:spPr>
           <a:xfrm>
-            <a:off x="722376" y="1664211"/>
-            <a:ext cx="3986783" cy="3136392"/>
+            <a:off x="722376" y="1389888"/>
+            <a:ext cx="3986783" cy="3364992"/>
           </a:xfrm>
           <a:prstGeom prst="rect">
             <a:avLst/>
@@ -21386,16 +21386,25 @@
                 </a:solidFill>
                 <a:latin typeface="Arial"/>
               </a:rPr>
-              <a:t>AI agents</a:t>
-            </a:r>
-            <a:r>
-              <a:rPr sz="1150" b="0" dirty="0">
+              <a:t>A</a:t>
+            </a:r>
+            <a:r>
+              <a:rPr lang="en-US" sz="1150" b="1" dirty="0">
                 <a:solidFill>
                   <a:srgbClr val="3B2A54"/>
                 </a:solidFill>
                 <a:latin typeface="Arial"/>
               </a:rPr>
-              <a:t>: consolidation, action tracking and follow-ups, freeing the team for judgment.</a:t>
+              <a:t>I-enabled processes</a:t>
+            </a:r>
+            <a:r>
+              <a:rPr lang="en-US" sz="1150" b="0" dirty="0">
+                <a:solidFill>
+                  <a:srgbClr val="3B2A54"/>
+                </a:solidFill>
+                <a:latin typeface="Arial"/>
+              </a:rPr>
+              <a:t>: agents to support consolidation, tracking action items, facilitating alignment and reducing manual work. </a:t>
             </a:r>
           </a:p>
           <a:p>
@@ -22613,7 +22622,7 @@
                 </a:solidFill>
                 <a:latin typeface="Arial"/>
               </a:rPr>
-              <a:t>Using AI to take the manual work out keeps the function light, where large companies get heavy</a:t>
+              <a:t>Leveraging AI processes to speed up manual work helps avoid the pitfalls seen in large companies</a:t>
             </a:r>
             <a:endParaRPr sz="1050" b="0" dirty="0">
               <a:solidFill>
@@ -26747,7 +26756,7 @@
                 </a:solidFill>
                 <a:latin typeface="Arial"/>
               </a:rPr>
-              <a:t>Runs the calendar. Prepares briefs and tracks actions. Uses AI agents to cut the manual work. Liaises with Country</a:t>
+              <a:t>Runs the calendar. Prepares briefs and tracks actions. Leverages AI Agents for efficiency. Liaises with Country</a:t>
             </a:r>
             <a:r>
               <a:rPr lang="en-US" sz="1150" b="0" dirty="0">

</xml_diff>